<commit_message>
Slides: re-export sd-01-042 PPTX with every line at 10 words or fewer
Co-Authored-By: Claude Opus 5.5 <noreply@anthropic.com>
Claude-Session: https://claude.ai/code/session_01PmqNRWe4NoiAuhPfHYj9Qq
</commit_message>
<xml_diff>
--- a/system-design-101/vi/lessons/sd-01-042/slides/sd-01-042.pptx
+++ b/system-design-101/vi/lessons/sd-01-042/slides/sd-01-042.pptx
@@ -1891,17 +1891,6 @@
               <a:t> cầu</a:t>
             </a:r>
             <a:r>
-              <a:rPr lang="en-US" sz="3000" dirty="0" spc="42" kern="0">
-                <a:solidFill>
-                  <a:srgbClr val="E4E1D8"/>
-                </a:solidFill>
-                <a:latin typeface="Be Vietnam Pro" pitchFamily="34" charset="0"/>
-                <a:ea typeface="Be Vietnam Pro" pitchFamily="34" charset="-122"/>
-                <a:cs typeface="Be Vietnam Pro" pitchFamily="34" charset="-120"/>
-              </a:rPr>
-              <a:t> đi</a:t>
-            </a:r>
-            <a:r>
               <a:rPr lang="en-US" sz="3000" dirty="0" spc="-12" kern="0">
                 <a:solidFill>
                   <a:srgbClr val="E4E1D8"/>
@@ -2029,10 +2018,10 @@
                 <a:ea typeface="Be Vietnam Pro" pitchFamily="34" charset="-122"/>
                 <a:cs typeface="Be Vietnam Pro" pitchFamily="34" charset="-120"/>
               </a:rPr>
-              <a:t> vụ</a:t>
-            </a:r>
-            <a:r>
-              <a:rPr lang="en-US" sz="2100" dirty="0" spc="-3" kern="0">
+              <a:t> vụ,</a:t>
+            </a:r>
+            <a:r>
+              <a:rPr lang="en-US" sz="2100" dirty="0" spc="-4" kern="0">
                 <a:solidFill>
                   <a:srgbClr val="9AA0B5"/>
                 </a:solidFill>
@@ -2040,10 +2029,10 @@
                 <a:ea typeface="Be Vietnam Pro" pitchFamily="34" charset="-122"/>
                 <a:cs typeface="Be Vietnam Pro" pitchFamily="34" charset="-120"/>
               </a:rPr>
-              <a:t> ·</a:t>
-            </a:r>
-            <a:r>
-              <a:rPr lang="en-US" sz="2100" dirty="0" spc="-5" kern="0">
+              <a:t> áp</a:t>
+            </a:r>
+            <a:r>
+              <a:rPr lang="en-US" sz="2100" dirty="0" spc="0" kern="0">
                 <a:solidFill>
                   <a:srgbClr val="9AA0B5"/>
                 </a:solidFill>
@@ -2051,43 +2040,21 @@
                 <a:ea typeface="Be Vietnam Pro" pitchFamily="34" charset="-122"/>
                 <a:cs typeface="Be Vietnam Pro" pitchFamily="34" charset="-120"/>
               </a:rPr>
-              <a:t> áp</a:t>
+              <a:t> chính</a:t>
+            </a:r>
+            <a:r>
+              <a:rPr lang="en-US" sz="2100" dirty="0" spc="-4" kern="0">
+                <a:solidFill>
+                  <a:srgbClr val="9AA0B5"/>
+                </a:solidFill>
+                <a:latin typeface="Be Vietnam Pro" pitchFamily="34" charset="0"/>
+                <a:ea typeface="Be Vietnam Pro" pitchFamily="34" charset="-122"/>
+                <a:cs typeface="Be Vietnam Pro" pitchFamily="34" charset="-120"/>
+              </a:rPr>
+              <a:t> sách,</a:t>
             </a:r>
             <a:r>
               <a:rPr lang="en-US" sz="2100" dirty="0" spc="0" kern="0">
-                <a:solidFill>
-                  <a:srgbClr val="9AA0B5"/>
-                </a:solidFill>
-                <a:latin typeface="Be Vietnam Pro" pitchFamily="34" charset="0"/>
-                <a:ea typeface="Be Vietnam Pro" pitchFamily="34" charset="-122"/>
-                <a:cs typeface="Be Vietnam Pro" pitchFamily="34" charset="-120"/>
-              </a:rPr>
-              <a:t> chính</a:t>
-            </a:r>
-            <a:r>
-              <a:rPr lang="en-US" sz="2100" dirty="0" spc="-5" kern="0">
-                <a:solidFill>
-                  <a:srgbClr val="9AA0B5"/>
-                </a:solidFill>
-                <a:latin typeface="Be Vietnam Pro" pitchFamily="34" charset="0"/>
-                <a:ea typeface="Be Vietnam Pro" pitchFamily="34" charset="-122"/>
-                <a:cs typeface="Be Vietnam Pro" pitchFamily="34" charset="-120"/>
-              </a:rPr>
-              <a:t> sách</a:t>
-            </a:r>
-            <a:r>
-              <a:rPr lang="en-US" sz="2100" dirty="0" spc="-3" kern="0">
-                <a:solidFill>
-                  <a:srgbClr val="9AA0B5"/>
-                </a:solidFill>
-                <a:latin typeface="Be Vietnam Pro" pitchFamily="34" charset="0"/>
-                <a:ea typeface="Be Vietnam Pro" pitchFamily="34" charset="-122"/>
-                <a:cs typeface="Be Vietnam Pro" pitchFamily="34" charset="-120"/>
-              </a:rPr>
-              <a:t> ·</a:t>
-            </a:r>
-            <a:r>
-              <a:rPr lang="en-US" sz="2100" dirty="0" spc="1" kern="0">
                 <a:solidFill>
                   <a:srgbClr val="9AA0B5"/>
                 </a:solidFill>
@@ -9960,7 +9927,7 @@
               <a:buNone/>
             </a:pPr>
             <a:r>
-              <a:rPr lang="en-US" sz="2550" dirty="0" spc="-77" kern="0">
+              <a:rPr lang="en-US" sz="2550" dirty="0" spc="1" kern="0">
                 <a:solidFill>
                   <a:srgbClr val="14161C"/>
                 </a:solidFill>
@@ -9968,7 +9935,18 @@
                 <a:ea typeface="Be Vietnam Pro" pitchFamily="34" charset="-122"/>
                 <a:cs typeface="Be Vietnam Pro" pitchFamily="34" charset="-120"/>
               </a:rPr>
-              <a:t>Tạm</a:t>
+              <a:t>Chỉ</a:t>
+            </a:r>
+            <a:r>
+              <a:rPr lang="en-US" sz="2550" dirty="0" spc="-11" kern="0">
+                <a:solidFill>
+                  <a:srgbClr val="14161C"/>
+                </a:solidFill>
+                <a:latin typeface="Be Vietnam Pro" pitchFamily="34" charset="0"/>
+                <a:ea typeface="Be Vietnam Pro" pitchFamily="34" charset="-122"/>
+                <a:cs typeface="Be Vietnam Pro" pitchFamily="34" charset="-120"/>
+              </a:rPr>
+              <a:t> tạm</a:t>
             </a:r>
             <a:r>
               <a:rPr lang="en-US" sz="2550" dirty="0" spc="0" kern="0">
@@ -9993,7 +9971,7 @@
               <a:t> gọi</a:t>
             </a:r>
             <a:r>
-              <a:rPr lang="en-US" sz="2550" dirty="0" spc="0" kern="0">
+              <a:rPr lang="en-US" sz="2550" dirty="0" spc="1" kern="0">
                 <a:solidFill>
                   <a:srgbClr val="14161C"/>
                 </a:solidFill>
@@ -10012,62 +9990,7 @@
                 <a:ea typeface="Be Vietnam Pro" pitchFamily="34" charset="-122"/>
                 <a:cs typeface="Be Vietnam Pro" pitchFamily="34" charset="-120"/>
               </a:rPr>
-              <a:t> lỗi,</a:t>
-            </a:r>
-            <a:r>
-              <a:rPr lang="en-US" sz="2550" dirty="0" spc="1" kern="0">
-                <a:solidFill>
-                  <a:srgbClr val="14161C"/>
-                </a:solidFill>
-                <a:latin typeface="Be Vietnam Pro" pitchFamily="34" charset="0"/>
-                <a:ea typeface="Be Vietnam Pro" pitchFamily="34" charset="-122"/>
-                <a:cs typeface="Be Vietnam Pro" pitchFamily="34" charset="-120"/>
-              </a:rPr>
-              <a:t> không</a:t>
-            </a:r>
-            <a:r>
-              <a:rPr lang="en-US" sz="2550" dirty="0" spc="-12" kern="0">
-                <a:solidFill>
-                  <a:srgbClr val="14161C"/>
-                </a:solidFill>
-                <a:latin typeface="Be Vietnam Pro" pitchFamily="34" charset="0"/>
-                <a:ea typeface="Be Vietnam Pro" pitchFamily="34" charset="-122"/>
-                <a:cs typeface="Be Vietnam Pro" pitchFamily="34" charset="-120"/>
-              </a:rPr>
-              <a:t> tạo</a:t>
-            </a:r>
-            <a:r>
-              <a:rPr lang="en-US" sz="2550" dirty="0" spc="-3" kern="0">
-                <a:solidFill>
-                  <a:srgbClr val="14161C"/>
-                </a:solidFill>
-                <a:latin typeface="Be Vietnam Pro" pitchFamily="34" charset="0"/>
-                <a:ea typeface="Be Vietnam Pro" pitchFamily="34" charset="-122"/>
-                <a:cs typeface="Be Vietnam Pro" pitchFamily="34" charset="-120"/>
-              </a:rPr>
-              <a:t> bản</a:t>
-            </a:r>
-            <a:r>
-              <a:rPr lang="en-US" sz="2550" dirty="0" spc="-8" kern="0">
-                <a:solidFill>
-                  <a:srgbClr val="14161C"/>
-                </a:solidFill>
-                <a:latin typeface="Be Vietnam Pro" pitchFamily="34" charset="0"/>
-                <a:ea typeface="Be Vietnam Pro" pitchFamily="34" charset="-122"/>
-                <a:cs typeface="Be Vietnam Pro" pitchFamily="34" charset="-120"/>
-              </a:rPr>
-              <a:t> thay</a:t>
-            </a:r>
-            <a:r>
-              <a:rPr lang="en-US" sz="2550" dirty="0" spc="2" kern="0">
-                <a:solidFill>
-                  <a:srgbClr val="14161C"/>
-                </a:solidFill>
-                <a:latin typeface="Be Vietnam Pro" pitchFamily="34" charset="0"/>
-                <a:ea typeface="Be Vietnam Pro" pitchFamily="34" charset="-122"/>
-                <a:cs typeface="Be Vietnam Pro" pitchFamily="34" charset="-120"/>
-              </a:rPr>
-              <a:t> thế</a:t>
+              <a:t> lỗi</a:t>
             </a:r>
             <a:endParaRPr lang="en-US" sz="2550" dirty="0"/>
           </a:p>
@@ -10900,7 +10823,7 @@
               <a:t> thất</a:t>
             </a:r>
             <a:r>
-              <a:rPr lang="en-US" sz="2250" dirty="0" spc="-4" kern="0">
+              <a:rPr lang="en-US" sz="2250" dirty="0" spc="-1" kern="0">
                 <a:solidFill>
                   <a:srgbClr val="C9CDD8"/>
                 </a:solidFill>
@@ -10908,40 +10831,7 @@
                 <a:ea typeface="Be Vietnam Pro" pitchFamily="34" charset="-122"/>
                 <a:cs typeface="Be Vietnam Pro" pitchFamily="34" charset="-120"/>
               </a:rPr>
-              <a:t> bại,</a:t>
-            </a:r>
-            <a:r>
-              <a:rPr lang="en-US" sz="2250" dirty="0" spc="3" kern="0">
-                <a:solidFill>
-                  <a:srgbClr val="C9CDD8"/>
-                </a:solidFill>
-                <a:latin typeface="Be Vietnam Pro" pitchFamily="34" charset="0"/>
-                <a:ea typeface="Be Vietnam Pro" pitchFamily="34" charset="-122"/>
-                <a:cs typeface="Be Vietnam Pro" pitchFamily="34" charset="-120"/>
-              </a:rPr>
-              <a:t> thử</a:t>
-            </a:r>
-            <a:r>
-              <a:rPr lang="en-US" sz="2250" dirty="0" spc="-2" kern="0">
-                <a:solidFill>
-                  <a:srgbClr val="C9CDD8"/>
-                </a:solidFill>
-                <a:latin typeface="Be Vietnam Pro" pitchFamily="34" charset="0"/>
-                <a:ea typeface="Be Vietnam Pro" pitchFamily="34" charset="-122"/>
-                <a:cs typeface="Be Vietnam Pro" pitchFamily="34" charset="-120"/>
-              </a:rPr>
-              <a:t> lại</a:t>
-            </a:r>
-            <a:r>
-              <a:rPr lang="en-US" sz="2250" dirty="0" spc="-3" kern="0">
-                <a:solidFill>
-                  <a:srgbClr val="C9CDD8"/>
-                </a:solidFill>
-                <a:latin typeface="Be Vietnam Pro" pitchFamily="34" charset="0"/>
-                <a:ea typeface="Be Vietnam Pro" pitchFamily="34" charset="-122"/>
-                <a:cs typeface="Be Vietnam Pro" pitchFamily="34" charset="-120"/>
-              </a:rPr>
-              <a:t> sau.</a:t>
+              <a:t> bại.</a:t>
             </a:r>
             <a:endParaRPr lang="en-US" sz="2250" dirty="0"/>
           </a:p>
@@ -12322,7 +12212,7 @@
               <a:t> dữ</a:t>
             </a:r>
             <a:r>
-              <a:rPr lang="en-US" sz="2700" dirty="0" spc="0" kern="0">
+              <a:rPr lang="en-US" sz="2700" dirty="0" spc="-1" kern="0">
                 <a:solidFill>
                   <a:srgbClr val="F3EEE3"/>
                 </a:solidFill>
@@ -12330,29 +12220,7 @@
                 <a:ea typeface="Be Vietnam Pro" pitchFamily="34" charset="-122"/>
                 <a:cs typeface="Be Vietnam Pro" pitchFamily="34" charset="-120"/>
               </a:rPr>
-              <a:t> liệu,</a:t>
-            </a:r>
-            <a:r>
-              <a:rPr lang="en-US" sz="2700" dirty="0" spc="8" kern="0">
-                <a:solidFill>
-                  <a:srgbClr val="F3EEE3"/>
-                </a:solidFill>
-                <a:latin typeface="Be Vietnam Pro" pitchFamily="34" charset="0"/>
-                <a:ea typeface="Be Vietnam Pro" pitchFamily="34" charset="-122"/>
-                <a:cs typeface="Be Vietnam Pro" pitchFamily="34" charset="-120"/>
-              </a:rPr>
-              <a:t> chức</a:t>
-            </a:r>
-            <a:r>
-              <a:rPr lang="en-US" sz="2700" dirty="0" spc="-2" kern="0">
-                <a:solidFill>
-                  <a:srgbClr val="F3EEE3"/>
-                </a:solidFill>
-                <a:latin typeface="Be Vietnam Pro" pitchFamily="34" charset="0"/>
-                <a:ea typeface="Be Vietnam Pro" pitchFamily="34" charset="-122"/>
-                <a:cs typeface="Be Vietnam Pro" pitchFamily="34" charset="-120"/>
-              </a:rPr>
-              <a:t> năng</a:t>
+              <a:t> liệu</a:t>
             </a:r>
             <a:endParaRPr lang="en-US" sz="2700" dirty="0"/>
           </a:p>

</xml_diff>

<commit_message>
Slides: code labels in Be Vietnam Pro on sd-01-042 and sd-01-043, re-export badged PPTX
Co-Authored-By: Claude Opus 5.5 <noreply@anthropic.com>
Claude-Session: https://claude.ai/code/session_01PmqNRWe4NoiAuhPfHYj9Qq
</commit_message>
<xml_diff>
--- a/system-design-101/vi/lessons/sd-01-042/slides/sd-01-042.pptx
+++ b/system-design-101/vi/lessons/sd-01-042/slides/sd-01-042.pptx
@@ -31,12 +31,8 @@
       <p:regular r:id="rId17"/>
     </p:embeddedFont>
     <p:embeddedFont>
-      <p:font typeface="Roboto Mono"/>
-      <p:bold r:id="rId19"/>
-    </p:embeddedFont>
-    <p:embeddedFont>
       <p:font typeface="Be Vietnam Pro SemiBold"/>
-      <p:regular r:id="rId20"/>
+      <p:regular r:id="rId19"/>
     </p:embeddedFont>
   </p:embeddedFontLst>
   <p:defaultTextStyle>
@@ -2537,13 +2533,13 @@
               <a:buNone/>
             </a:pPr>
             <a:r>
-              <a:rPr lang="en-US" sz="2250" b="1" dirty="0" kern="0">
+              <a:rPr lang="en-US" sz="2250" b="1" dirty="0" spc="-16" kern="0">
                 <a:solidFill>
                   <a:srgbClr val="3DD6A0"/>
                 </a:solidFill>
-                <a:latin typeface="Roboto Mono" pitchFamily="34" charset="0"/>
-                <a:ea typeface="Roboto Mono" pitchFamily="34" charset="-122"/>
-                <a:cs typeface="Roboto Mono" pitchFamily="34" charset="-120"/>
+                <a:latin typeface="Be Vietnam Pro" pitchFamily="34" charset="0"/>
+                <a:ea typeface="Be Vietnam Pro" pitchFamily="34" charset="-122"/>
+                <a:cs typeface="Be Vietnam Pro" pitchFamily="34" charset="-120"/>
               </a:rPr>
               <a:t>/books</a:t>
             </a:r>
@@ -2576,13 +2572,13 @@
               <a:buNone/>
             </a:pPr>
             <a:r>
-              <a:rPr lang="en-US" sz="2250" b="1" dirty="0" kern="0">
+              <a:rPr lang="en-US" sz="2250" b="1" dirty="0" spc="-2" kern="0">
                 <a:solidFill>
                   <a:srgbClr val="7C93FF"/>
                 </a:solidFill>
-                <a:latin typeface="Roboto Mono" pitchFamily="34" charset="0"/>
-                <a:ea typeface="Roboto Mono" pitchFamily="34" charset="-122"/>
-                <a:cs typeface="Roboto Mono" pitchFamily="34" charset="-120"/>
+                <a:latin typeface="Be Vietnam Pro" pitchFamily="34" charset="0"/>
+                <a:ea typeface="Be Vietnam Pro" pitchFamily="34" charset="-122"/>
+                <a:cs typeface="Be Vietnam Pro" pitchFamily="34" charset="-120"/>
               </a:rPr>
               <a:t>/loans</a:t>
             </a:r>
@@ -4156,13 +4152,13 @@
               <a:buNone/>
             </a:pPr>
             <a:r>
-              <a:rPr lang="en-US" sz="3600" b="1" dirty="0" spc="-2" kern="0">
+              <a:rPr lang="en-US" sz="3600" b="1" dirty="0" spc="-32" kern="0">
                 <a:solidFill>
                   <a:srgbClr val="0F766E"/>
                 </a:solidFill>
-                <a:latin typeface="Roboto Mono" pitchFamily="34" charset="0"/>
-                <a:ea typeface="Roboto Mono" pitchFamily="34" charset="-122"/>
-                <a:cs typeface="Roboto Mono" pitchFamily="34" charset="-120"/>
+                <a:latin typeface="Be Vietnam Pro" pitchFamily="34" charset="0"/>
+                <a:ea typeface="Be Vietnam Pro" pitchFamily="34" charset="-122"/>
+                <a:cs typeface="Be Vietnam Pro" pitchFamily="34" charset="-120"/>
               </a:rPr>
               <a:t>/books</a:t>
             </a:r>
@@ -4339,13 +4335,13 @@
               <a:buNone/>
             </a:pPr>
             <a:r>
-              <a:rPr lang="en-US" sz="3600" b="1" dirty="0" spc="-2" kern="0">
+              <a:rPr lang="en-US" sz="3600" b="1" dirty="0" spc="-8" kern="0">
                 <a:solidFill>
                   <a:srgbClr val="0F766E"/>
                 </a:solidFill>
-                <a:latin typeface="Roboto Mono" pitchFamily="34" charset="0"/>
-                <a:ea typeface="Roboto Mono" pitchFamily="34" charset="-122"/>
-                <a:cs typeface="Roboto Mono" pitchFamily="34" charset="-120"/>
+                <a:latin typeface="Be Vietnam Pro" pitchFamily="34" charset="0"/>
+                <a:ea typeface="Be Vietnam Pro" pitchFamily="34" charset="-122"/>
+                <a:cs typeface="Be Vietnam Pro" pitchFamily="34" charset="-120"/>
               </a:rPr>
               <a:t>/loans</a:t>
             </a:r>

</xml_diff>